<commit_message>
add data for last lecture
</commit_message>
<xml_diff>
--- a/LPHY1365/decalage.pptx
+++ b/LPHY1365/decalage.pptx
@@ -107,6 +107,11 @@
       </a:defRPr>
     </a:lvl9pPr>
   </p:defaultTextStyle>
+  <p:extLst>
+    <p:ext uri="{EFAFB233-063F-42B5-8137-9DF3F51BA10A}">
+      <p15:sldGuideLst xmlns:p15="http://schemas.microsoft.com/office/powerpoint/2012/main"/>
+    </p:ext>
+  </p:extLst>
 </p:presentation>
 </file>
 
@@ -192,7 +197,7 @@
           <a:p>
             <a:fld id="{FE72DE3D-A737-C04E-B8A0-8A9BEC4B51C3}" type="datetimeFigureOut">
               <a:rPr lang="fr-FR" smtClean="0"/>
-              <a:t>16/03/2026</a:t>
+              <a:t>17/03/2026</a:t>
             </a:fld>
             <a:endParaRPr lang="fr-FR"/>
           </a:p>
@@ -705,7 +710,7 @@
           <a:p>
             <a:fld id="{3465FB68-F8AA-904D-8ADA-6BA591A83098}" type="datetimeFigureOut">
               <a:rPr lang="fr-FR" smtClean="0"/>
-              <a:t>16/03/2026</a:t>
+              <a:t>17/03/2026</a:t>
             </a:fld>
             <a:endParaRPr lang="fr-FR"/>
           </a:p>
@@ -903,7 +908,7 @@
           <a:p>
             <a:fld id="{3465FB68-F8AA-904D-8ADA-6BA591A83098}" type="datetimeFigureOut">
               <a:rPr lang="fr-FR" smtClean="0"/>
-              <a:t>16/03/2026</a:t>
+              <a:t>17/03/2026</a:t>
             </a:fld>
             <a:endParaRPr lang="fr-FR"/>
           </a:p>
@@ -1111,7 +1116,7 @@
           <a:p>
             <a:fld id="{3465FB68-F8AA-904D-8ADA-6BA591A83098}" type="datetimeFigureOut">
               <a:rPr lang="fr-FR" smtClean="0"/>
-              <a:t>16/03/2026</a:t>
+              <a:t>17/03/2026</a:t>
             </a:fld>
             <a:endParaRPr lang="fr-FR"/>
           </a:p>
@@ -1309,7 +1314,7 @@
           <a:p>
             <a:fld id="{3465FB68-F8AA-904D-8ADA-6BA591A83098}" type="datetimeFigureOut">
               <a:rPr lang="fr-FR" smtClean="0"/>
-              <a:t>16/03/2026</a:t>
+              <a:t>17/03/2026</a:t>
             </a:fld>
             <a:endParaRPr lang="fr-FR"/>
           </a:p>
@@ -1584,7 +1589,7 @@
           <a:p>
             <a:fld id="{3465FB68-F8AA-904D-8ADA-6BA591A83098}" type="datetimeFigureOut">
               <a:rPr lang="fr-FR" smtClean="0"/>
-              <a:t>16/03/2026</a:t>
+              <a:t>17/03/2026</a:t>
             </a:fld>
             <a:endParaRPr lang="fr-FR"/>
           </a:p>
@@ -1849,7 +1854,7 @@
           <a:p>
             <a:fld id="{3465FB68-F8AA-904D-8ADA-6BA591A83098}" type="datetimeFigureOut">
               <a:rPr lang="fr-FR" smtClean="0"/>
-              <a:t>16/03/2026</a:t>
+              <a:t>17/03/2026</a:t>
             </a:fld>
             <a:endParaRPr lang="fr-FR"/>
           </a:p>
@@ -2261,7 +2266,7 @@
           <a:p>
             <a:fld id="{3465FB68-F8AA-904D-8ADA-6BA591A83098}" type="datetimeFigureOut">
               <a:rPr lang="fr-FR" smtClean="0"/>
-              <a:t>16/03/2026</a:t>
+              <a:t>17/03/2026</a:t>
             </a:fld>
             <a:endParaRPr lang="fr-FR"/>
           </a:p>
@@ -2402,7 +2407,7 @@
           <a:p>
             <a:fld id="{3465FB68-F8AA-904D-8ADA-6BA591A83098}" type="datetimeFigureOut">
               <a:rPr lang="fr-FR" smtClean="0"/>
-              <a:t>16/03/2026</a:t>
+              <a:t>17/03/2026</a:t>
             </a:fld>
             <a:endParaRPr lang="fr-FR"/>
           </a:p>
@@ -2515,7 +2520,7 @@
           <a:p>
             <a:fld id="{3465FB68-F8AA-904D-8ADA-6BA591A83098}" type="datetimeFigureOut">
               <a:rPr lang="fr-FR" smtClean="0"/>
-              <a:t>16/03/2026</a:t>
+              <a:t>17/03/2026</a:t>
             </a:fld>
             <a:endParaRPr lang="fr-FR"/>
           </a:p>
@@ -2826,7 +2831,7 @@
           <a:p>
             <a:fld id="{3465FB68-F8AA-904D-8ADA-6BA591A83098}" type="datetimeFigureOut">
               <a:rPr lang="fr-FR" smtClean="0"/>
-              <a:t>16/03/2026</a:t>
+              <a:t>17/03/2026</a:t>
             </a:fld>
             <a:endParaRPr lang="fr-FR"/>
           </a:p>
@@ -3114,7 +3119,7 @@
           <a:p>
             <a:fld id="{3465FB68-F8AA-904D-8ADA-6BA591A83098}" type="datetimeFigureOut">
               <a:rPr lang="fr-FR" smtClean="0"/>
-              <a:t>16/03/2026</a:t>
+              <a:t>17/03/2026</a:t>
             </a:fld>
             <a:endParaRPr lang="fr-FR"/>
           </a:p>
@@ -3355,7 +3360,7 @@
           <a:p>
             <a:fld id="{3465FB68-F8AA-904D-8ADA-6BA591A83098}" type="datetimeFigureOut">
               <a:rPr lang="fr-FR" smtClean="0"/>
-              <a:t>16/03/2026</a:t>
+              <a:t>17/03/2026</a:t>
             </a:fld>
             <a:endParaRPr lang="fr-FR"/>
           </a:p>

</xml_diff>